<commit_message>
Use real CDX tenant users directly; remove profile mapping
Co-authored-by: Copilot <223556219+Copilot@users.noreply.github.com>
Copilot-Session: 91e57aab-4107-4707-97d7-02508420b523
</commit_message>
<xml_diff>
--- a/powerpoint-copilot/Contoso_Fargo_Update_Branded.pptx
+++ b/powerpoint-copilot/Contoso_Fargo_Update_Branded.pptx
@@ -4002,7 +4002,7 @@
                 </a:solidFill>
                 <a:latin typeface="Segoe UI"/>
               </a:rPr>
-              <a:t>Carriers are informed; two still need confirmation (Megan).</a:t>
+              <a:t>Carriers are informed; two still need confirmation (Lisa).</a:t>
             </a:r>
           </a:p>
           <a:p>
@@ -4034,7 +4034,7 @@
                 </a:solidFill>
                 <a:latin typeface="Segoe UI"/>
               </a:rPr>
-              <a:t>Yellow forklift floor markings in Hall 2 ordered (Riley).</a:t>
+              <a:t>Yellow forklift floor markings in Hall 2 ordered (Kai).</a:t>
             </a:r>
           </a:p>
         </p:txBody>
@@ -4245,7 +4245,7 @@
                 </a:solidFill>
                 <a:latin typeface="Segoe UI"/>
               </a:rPr>
-              <a:t>Updated evacuation maps go up in every hall this week (Anne).</a:t>
+              <a:t>Updated evacuation maps go up in every hall this week (Sonia).</a:t>
             </a:r>
           </a:p>
         </p:txBody>
@@ -4551,7 +4551,7 @@
                           </a:solidFill>
                           <a:latin typeface="Segoe UI"/>
                         </a:rPr>
-                        <a:t>Megan</a:t>
+                        <a:t>Lisa</a:t>
                       </a:r>
                     </a:p>
                   </a:txBody>
@@ -4687,7 +4687,7 @@
                           </a:solidFill>
                           <a:latin typeface="Segoe UI"/>
                         </a:rPr>
-                        <a:t>Anne</a:t>
+                        <a:t>Sonia</a:t>
                       </a:r>
                     </a:p>
                   </a:txBody>
@@ -4755,7 +4755,7 @@
                           </a:solidFill>
                           <a:latin typeface="Segoe UI"/>
                         </a:rPr>
-                        <a:t>Riley</a:t>
+                        <a:t>Kai</a:t>
                       </a:r>
                     </a:p>
                   </a:txBody>

</xml_diff>

<commit_message>
Recast to CDX users with a mailbox; guard against look-alike mailboxes; desktop log for every run
Co-authored-by: Copilot <223556219+Copilot@users.noreply.github.com>
Copilot-Session: 91e57aab-4107-4707-97d7-02508420b523
</commit_message>
<xml_diff>
--- a/powerpoint-copilot/Contoso_Fargo_Update_Branded.pptx
+++ b/powerpoint-copilot/Contoso_Fargo_Update_Branded.pptx
@@ -4002,7 +4002,7 @@
                 </a:solidFill>
                 <a:latin typeface="Segoe UI"/>
               </a:rPr>
-              <a:t>Carriers are informed; two still need confirmation (Lisa).</a:t>
+              <a:t>Carriers are informed; two still need confirmation (Teresa).</a:t>
             </a:r>
           </a:p>
           <a:p>
@@ -4034,7 +4034,7 @@
                 </a:solidFill>
                 <a:latin typeface="Segoe UI"/>
               </a:rPr>
-              <a:t>Yellow forklift floor markings in Hall 2 ordered (Kai).</a:t>
+              <a:t>Yellow forklift floor markings in Hall 2 ordered (Vance).</a:t>
             </a:r>
           </a:p>
         </p:txBody>
@@ -4551,7 +4551,7 @@
                           </a:solidFill>
                           <a:latin typeface="Segoe UI"/>
                         </a:rPr>
-                        <a:t>Lisa</a:t>
+                        <a:t>Teresa</a:t>
                       </a:r>
                     </a:p>
                   </a:txBody>
@@ -4755,7 +4755,7 @@
                           </a:solidFill>
                           <a:latin typeface="Segoe UI"/>
                         </a:rPr>
-                        <a:t>Kai</a:t>
+                        <a:t>Vance</a:t>
                       </a:r>
                     </a:p>
                   </a:txBody>

</xml_diff>